<commit_message>
docs(ppt): corregir metricas Frontend en slide 17 (18/18 en 3 suites)
El conteo anterior asumia sin suite en Frontend; jest confirma 3 suites y 18 tests pasando. Se actualiza la tarjeta y la nota de verificacion.
</commit_message>
<xml_diff>
--- a/Docs/TechShield_Presentacion.pptx
+++ b/Docs/TechShield_Presentacion.pptx
@@ -12813,7 +12813,7 @@
                 </a:solidFill>
                 <a:latin typeface="Consolas"/>
               </a:rPr>
-              <a:t>—</a:t>
+              <a:t>18</a:t>
             </a:r>
           </a:p>
         </p:txBody>
@@ -12852,7 +12852,7 @@
                 </a:solidFill>
                 <a:latin typeface="Aptos"/>
               </a:rPr>
-              <a:t>tsc + lint OK</a:t>
+              <a:t>Tests unitarios</a:t>
             </a:r>
           </a:p>
         </p:txBody>
@@ -13014,7 +13014,7 @@
                 </a:solidFill>
                 <a:latin typeface="Aptos"/>
               </a:rPr>
-              <a:t>Suite unitaria re-ejecutada: 215/215 ✔ en 19 suites (oct-2026).</a:t>
+              <a:t>Backend 215/215 ✔ (19 suites) · Frontend 18/18 ✔ (3 suites) · oct-2026.</a:t>
             </a:r>
           </a:p>
         </p:txBody>

</xml_diff>